<commit_message>
docs(S-K8S): retrofit summary.json for both suite-done cases + add pipeline-log.md
- summary.json × 2: generated by tests/common/summary-from-stdout.py v1
  - tidb-k8s-3node-haproxy-3s3r-unlimit-rc-20260608T165403+0800
  - tidb-k8s-3node-haproxy-3s3r-limit-rc-20260608T210453+0800
- pipeline-log.md: S-K8S-only thread sweep + VM baseline 對標
  - t=128: VM 26,946.7 / unlimit 23,442.9 (87.0%) / limit 15,751.9 (58.5%)
  - limit cell t=128 反曲，peak 在 t=64 (15,936.2)
- 0626-slide-v4.pptx: touch (binary metadata only)

Co-Authored-By: Claude Opus 4.7 <noreply@anthropic.com>
</commit_message>
<xml_diff>
--- a/poc/1_MeetingMinutes/0626-slide-v4.pptx
+++ b/poc/1_MeetingMinutes/0626-slide-v4.pptx
@@ -4826,13 +4826,57 @@
           <a:p>
             <a:pPr algn="ctr"/>
             <a:r>
-              <a:rPr sz="1600" b="1">
-                <a:solidFill>
-                  <a:srgbClr val="FFFFFF"/>
-                </a:solidFill>
-              </a:rPr>
-              <a:t>短期</a:t>
-            </a:r>
+              <a:rPr lang="en-US" sz="1600" b="1" dirty="0">
+                <a:solidFill>
+                  <a:srgbClr val="FFFFFF"/>
+                </a:solidFill>
+              </a:rPr>
+              <a:t>EX: Y26/07</a:t>
+            </a:r>
+            <a:br>
+              <a:rPr lang="en-US" sz="1600" b="1" dirty="0">
+                <a:solidFill>
+                  <a:srgbClr val="FFFFFF"/>
+                </a:solidFill>
+              </a:rPr>
+            </a:br>
+            <a:r>
+              <a:rPr lang="en-US" sz="1600" b="1" dirty="0">
+                <a:solidFill>
+                  <a:srgbClr val="FFFFFF"/>
+                </a:solidFill>
+              </a:rPr>
+              <a:t>{</a:t>
+            </a:r>
+            <a:r>
+              <a:rPr lang="en-US" altLang="zh-TW" sz="1600" b="1" dirty="0">
+                <a:solidFill>
+                  <a:srgbClr val="FFFFFF"/>
+                </a:solidFill>
+              </a:rPr>
+              <a:t>FIXME</a:t>
+            </a:r>
+            <a:r>
+              <a:rPr lang="en-US" sz="1600" b="1" dirty="0">
+                <a:solidFill>
+                  <a:srgbClr val="FFFFFF"/>
+                </a:solidFill>
+              </a:rPr>
+              <a:t>}</a:t>
+            </a:r>
+            <a:r>
+              <a:rPr lang="zh-TW" altLang="en-US" sz="1600" b="1" dirty="0">
+                <a:solidFill>
+                  <a:srgbClr val="FFFFFF"/>
+                </a:solidFill>
+              </a:rPr>
+              <a:t> 補完完整測試時間描述</a:t>
+            </a:r>
+            <a:endParaRPr sz="1600" b="1" dirty="0">
+              <a:solidFill>
+                <a:srgbClr val="FFFFFF"/>
+              </a:solidFill>
+            </a:endParaRPr>
           </a:p>
         </p:txBody>
       </p:sp>
@@ -5136,13 +5180,18 @@
           <a:p>
             <a:pPr algn="ctr"/>
             <a:r>
-              <a:rPr sz="1600" b="1">
+              <a:rPr sz="1600" b="1" dirty="0" err="1">
                 <a:solidFill>
                   <a:srgbClr val="FFFFFF"/>
                 </a:solidFill>
               </a:rPr>
               <a:t>中期</a:t>
             </a:r>
+            <a:endParaRPr sz="1600" b="1" dirty="0">
+              <a:solidFill>
+                <a:srgbClr val="FFFFFF"/>
+              </a:solidFill>
+            </a:endParaRPr>
           </a:p>
         </p:txBody>
       </p:sp>
@@ -5263,7 +5312,29 @@
                   <a:srgbClr val="FFFF00"/>
                 </a:highlight>
               </a:rPr>
-              <a:t>P-A/P-B placement</a:t>
+              <a:t>P-A/P-B</a:t>
+            </a:r>
+            <a:r>
+              <a:rPr lang="en-US" sz="1200" dirty="0">
+                <a:solidFill>
+                  <a:srgbClr val="FF0000"/>
+                </a:solidFill>
+                <a:highlight>
+                  <a:srgbClr val="FFFF00"/>
+                </a:highlight>
+              </a:rPr>
+              <a:t> </a:t>
+            </a:r>
+            <a:r>
+              <a:rPr sz="1200" dirty="0">
+                <a:solidFill>
+                  <a:srgbClr val="FF0000"/>
+                </a:solidFill>
+                <a:highlight>
+                  <a:srgbClr val="FFFF00"/>
+                </a:highlight>
+              </a:rPr>
+              <a:t> placement</a:t>
             </a:r>
             <a:r>
               <a:rPr sz="1200" dirty="0">
@@ -10657,7 +10728,7 @@
           <p:nvPr>
             <p:extLst>
               <p:ext uri="{D42A27DB-BD31-4B8C-83A1-F6EECF244321}">
-                <p14:modId xmlns:p14="http://schemas.microsoft.com/office/powerpoint/2010/main" val="1599196922"/>
+                <p14:modId xmlns:p14="http://schemas.microsoft.com/office/powerpoint/2010/main" val="465427376"/>
               </p:ext>
             </p:extLst>
           </p:nvPr>
@@ -10943,13 +11014,82 @@
                     <a:p>
                       <a:pPr algn="l"/>
                       <a:r>
-                        <a:rPr sz="1200" b="0">
-                          <a:solidFill>
-                            <a:schemeClr val="tx1"/>
-                          </a:solidFill>
-                        </a:rPr>
-                        <a:t>建立多測項部署、HAProxy、VM / Kubernetes 流程及獨立壓測 client</a:t>
-                      </a:r>
+                        <a:rPr sz="1200" b="0" dirty="0" err="1">
+                          <a:solidFill>
+                            <a:schemeClr val="tx1"/>
+                          </a:solidFill>
+                        </a:rPr>
+                        <a:t>建立多測項部署、HAProxy、VM</a:t>
+                      </a:r>
+                      <a:r>
+                        <a:rPr sz="1200" b="0" dirty="0">
+                          <a:solidFill>
+                            <a:schemeClr val="tx1"/>
+                          </a:solidFill>
+                        </a:rPr>
+                        <a:t> / Kubernetes </a:t>
+                      </a:r>
+                      <a:r>
+                        <a:rPr sz="1200" b="0" dirty="0" err="1">
+                          <a:solidFill>
+                            <a:schemeClr val="tx1"/>
+                          </a:solidFill>
+                        </a:rPr>
+                        <a:t>流程及獨立壓測</a:t>
+                      </a:r>
+                      <a:r>
+                        <a:rPr sz="1200" b="0" dirty="0">
+                          <a:solidFill>
+                            <a:schemeClr val="tx1"/>
+                          </a:solidFill>
+                        </a:rPr>
+                        <a:t> client</a:t>
+                      </a:r>
+                      <a:endParaRPr lang="en-US" sz="1200" b="0" dirty="0">
+                        <a:solidFill>
+                          <a:schemeClr val="tx1"/>
+                        </a:solidFill>
+                      </a:endParaRPr>
+                    </a:p>
+                    <a:p>
+                      <a:pPr algn="l"/>
+                      <a:endParaRPr lang="en-US" sz="1200" b="0" dirty="0">
+                        <a:solidFill>
+                          <a:schemeClr val="tx1"/>
+                        </a:solidFill>
+                      </a:endParaRPr>
+                    </a:p>
+                    <a:p>
+                      <a:pPr algn="l"/>
+                      <a:r>
+                        <a:rPr lang="en-US" sz="1200" b="0" dirty="0">
+                          <a:solidFill>
+                            <a:schemeClr val="tx1"/>
+                          </a:solidFill>
+                        </a:rPr>
+                        <a:t>{FIXME} Chain </a:t>
+                      </a:r>
+                      <a:r>
+                        <a:rPr lang="en-US" sz="1200" b="0" dirty="0" err="1">
+                          <a:solidFill>
+                            <a:schemeClr val="tx1"/>
+                          </a:solidFill>
+                        </a:rPr>
+                        <a:t>的</a:t>
+                      </a:r>
+                      <a:r>
+                        <a:rPr lang="en-US" sz="1200" b="0" dirty="0">
+                          <a:solidFill>
+                            <a:schemeClr val="tx1"/>
+                          </a:solidFill>
+                        </a:rPr>
+                        <a:t> flow &amp; Key Point</a:t>
+                      </a:r>
+                      <a:endParaRPr sz="1200" b="0" dirty="0">
+                        <a:solidFill>
+                          <a:schemeClr val="tx1"/>
+                        </a:solidFill>
+                      </a:endParaRPr>
                     </a:p>
                   </a:txBody>
                   <a:tcPr/>
@@ -10961,13 +11101,26 @@
                     <a:p>
                       <a:pPr algn="l"/>
                       <a:r>
-                        <a:rPr sz="1200" b="1">
+                        <a:rPr sz="1200" b="1" dirty="0">
                           <a:solidFill>
                             <a:srgbClr val="27AE60"/>
                           </a:solidFill>
                         </a:rPr>
-                        <a:t>✅ 完成</a:t>
-                      </a:r>
+                        <a:t>✅ </a:t>
+                      </a:r>
+                      <a:r>
+                        <a:rPr sz="1200" b="1" dirty="0" err="1">
+                          <a:solidFill>
+                            <a:srgbClr val="27AE60"/>
+                          </a:solidFill>
+                        </a:rPr>
+                        <a:t>完成</a:t>
+                      </a:r>
+                      <a:endParaRPr sz="1200" b="1" dirty="0">
+                        <a:solidFill>
+                          <a:srgbClr val="27AE60"/>
+                        </a:solidFill>
+                      </a:endParaRPr>
                     </a:p>
                   </a:txBody>
                   <a:tcPr/>
@@ -11023,13 +11176,98 @@
                     <a:p>
                       <a:pPr algn="l"/>
                       <a:r>
-                        <a:rPr sz="1200" b="0">
-                          <a:solidFill>
-                            <a:schemeClr val="tx1"/>
-                          </a:solidFill>
-                        </a:rPr>
-                        <a:t>處理 BenchmarkSQL、bulk load、RF / schema packing 與 HAProxy 問題</a:t>
-                      </a:r>
+                        <a:rPr sz="1200" b="0" dirty="0" err="1">
+                          <a:solidFill>
+                            <a:schemeClr val="tx1"/>
+                          </a:solidFill>
+                        </a:rPr>
+                        <a:t>處理</a:t>
+                      </a:r>
+                      <a:r>
+                        <a:rPr sz="1200" b="0" dirty="0">
+                          <a:solidFill>
+                            <a:schemeClr val="tx1"/>
+                          </a:solidFill>
+                        </a:rPr>
+                        <a:t> </a:t>
+                      </a:r>
+                      <a:r>
+                        <a:rPr sz="1200" b="0" dirty="0" err="1">
+                          <a:solidFill>
+                            <a:schemeClr val="tx1"/>
+                          </a:solidFill>
+                        </a:rPr>
+                        <a:t>BenchmarkSQL、bulk</a:t>
+                      </a:r>
+                      <a:r>
+                        <a:rPr sz="1200" b="0" dirty="0">
+                          <a:solidFill>
+                            <a:schemeClr val="tx1"/>
+                          </a:solidFill>
+                        </a:rPr>
+                        <a:t> </a:t>
+                      </a:r>
+                      <a:r>
+                        <a:rPr sz="1200" b="0" dirty="0" err="1">
+                          <a:solidFill>
+                            <a:schemeClr val="tx1"/>
+                          </a:solidFill>
+                        </a:rPr>
+                        <a:t>load、RF</a:t>
+                      </a:r>
+                      <a:r>
+                        <a:rPr sz="1200" b="0" dirty="0">
+                          <a:solidFill>
+                            <a:schemeClr val="tx1"/>
+                          </a:solidFill>
+                        </a:rPr>
+                        <a:t> / schema packing </a:t>
+                      </a:r>
+                      <a:r>
+                        <a:rPr sz="1200" b="0" dirty="0" err="1">
+                          <a:solidFill>
+                            <a:schemeClr val="tx1"/>
+                          </a:solidFill>
+                        </a:rPr>
+                        <a:t>與</a:t>
+                      </a:r>
+                      <a:r>
+                        <a:rPr sz="1200" b="0" dirty="0">
+                          <a:solidFill>
+                            <a:schemeClr val="tx1"/>
+                          </a:solidFill>
+                        </a:rPr>
+                        <a:t> </a:t>
+                      </a:r>
+                      <a:r>
+                        <a:rPr sz="1200" b="0" dirty="0" err="1">
+                          <a:solidFill>
+                            <a:schemeClr val="tx1"/>
+                          </a:solidFill>
+                        </a:rPr>
+                        <a:t>HAProxy</a:t>
+                      </a:r>
+                      <a:r>
+                        <a:rPr sz="1200" b="0" dirty="0">
+                          <a:solidFill>
+                            <a:schemeClr val="tx1"/>
+                          </a:solidFill>
+                        </a:rPr>
+                        <a:t> </a:t>
+                      </a:r>
+                      <a:r>
+                        <a:rPr sz="1200" b="0" dirty="0" err="1">
+                          <a:solidFill>
+                            <a:schemeClr val="tx1"/>
+                          </a:solidFill>
+                        </a:rPr>
+                        <a:t>問題</a:t>
+                      </a:r>
+                      <a:endParaRPr sz="1200" b="0" dirty="0">
+                        <a:solidFill>
+                          <a:schemeClr val="tx1"/>
+                        </a:solidFill>
+                      </a:endParaRPr>
                     </a:p>
                   </a:txBody>
                   <a:tcPr/>
@@ -13351,7 +13589,7 @@
         <p:spPr>
           <a:xfrm>
             <a:off x="365760" y="228600"/>
-            <a:ext cx="11430000" cy="594360"/>
+            <a:ext cx="3416320" cy="523220"/>
           </a:xfrm>
           <a:prstGeom prst="rect">
             <a:avLst/>
@@ -13947,7 +14185,7 @@
         <p:spPr>
           <a:xfrm>
             <a:off x="365760" y="3429000"/>
-            <a:ext cx="5424370" cy="307777"/>
+            <a:ext cx="10321544" cy="523220"/>
           </a:xfrm>
           <a:prstGeom prst="rect">
             <a:avLst/>
@@ -14038,9 +14276,51 @@
                   <a:srgbClr val="F5A623"/>
                 </a:solidFill>
               </a:rPr>
-              <a:t>)</a:t>
-            </a:r>
-            <a:endParaRPr sz="1400" b="1" dirty="0">
+              <a:t>) {FIXME} </a:t>
+            </a:r>
+            <a:r>
+              <a:rPr lang="en-US" sz="1400" b="1" dirty="0" err="1">
+                <a:solidFill>
+                  <a:srgbClr val="F5A623"/>
+                </a:solidFill>
+              </a:rPr>
+              <a:t>測試架構圖補完</a:t>
+            </a:r>
+            <a:r>
+              <a:rPr lang="en-US" sz="1400" b="1" dirty="0">
+                <a:solidFill>
+                  <a:srgbClr val="F5A623"/>
+                </a:solidFill>
+              </a:rPr>
+              <a:t> ; </a:t>
+            </a:r>
+            <a:r>
+              <a:rPr lang="en-US" sz="1400" b="1" dirty="0" err="1">
+                <a:solidFill>
+                  <a:srgbClr val="F5A623"/>
+                </a:solidFill>
+              </a:rPr>
+              <a:t>db</a:t>
+            </a:r>
+            <a:r>
+              <a:rPr lang="en-US" sz="1400" b="1" dirty="0">
+                <a:solidFill>
+                  <a:srgbClr val="F5A623"/>
+                </a:solidFill>
+              </a:rPr>
+              <a:t> component intro ;</a:t>
+            </a:r>
+            <a:r>
+              <a:rPr lang="zh-TW" altLang="en-US" sz="1400" b="1" dirty="0">
+                <a:solidFill>
+                  <a:srgbClr val="F5A623"/>
+                </a:solidFill>
+              </a:rPr>
+              <a:t>各節點較重損耗</a:t>
+            </a:r>
+          </a:p>
+          <a:p>
+            <a:endParaRPr lang="zh-TW" altLang="en-US" sz="1400" b="1" dirty="0">
               <a:solidFill>
                 <a:srgbClr val="F5A623"/>
               </a:solidFill>
@@ -14054,7 +14334,13 @@
           <p:cNvGraphicFramePr>
             <a:graphicFrameLocks noGrp="1"/>
           </p:cNvGraphicFramePr>
-          <p:nvPr/>
+          <p:nvPr>
+            <p:extLst>
+              <p:ext uri="{D42A27DB-BD31-4B8C-83A1-F6EECF244321}">
+                <p14:modId xmlns:p14="http://schemas.microsoft.com/office/powerpoint/2010/main" val="1574159862"/>
+              </p:ext>
+            </p:extLst>
+          </p:nvPr>
         </p:nvGraphicFramePr>
         <p:xfrm>
           <a:off x="365760" y="3794760"/>
@@ -14172,7 +14458,7 @@
                       <a:r>
                         <a:rPr sz="2000" b="1" dirty="0">
                           <a:solidFill>
-                            <a:srgbClr val="F5A623"/>
+                            <a:schemeClr val="tx1"/>
                           </a:solidFill>
                         </a:rPr>
                         <a:t>≈ 26,900</a:t>
@@ -14188,9 +14474,9 @@
                     <a:p>
                       <a:pPr algn="ctr"/>
                       <a:r>
-                        <a:rPr sz="2000" b="1">
-                          <a:solidFill>
-                            <a:srgbClr val="F5A623"/>
+                        <a:rPr sz="2000" b="1" dirty="0">
+                          <a:solidFill>
+                            <a:schemeClr val="tx1"/>
                           </a:solidFill>
                         </a:rPr>
                         <a:t>≈ 15,600</a:t>
@@ -14208,7 +14494,7 @@
                       <a:r>
                         <a:rPr sz="2000" b="1" dirty="0">
                           <a:solidFill>
-                            <a:srgbClr val="F5A623"/>
+                            <a:schemeClr val="tx1"/>
                           </a:solidFill>
                         </a:rPr>
                         <a:t>≈ 15,000</a:t>
@@ -15877,7 +16163,7 @@
         <p:spPr>
           <a:xfrm>
             <a:off x="365760" y="228600"/>
-            <a:ext cx="11430000" cy="594360"/>
+            <a:ext cx="4256614" cy="769441"/>
           </a:xfrm>
           <a:prstGeom prst="rect">
             <a:avLst/>
@@ -15914,7 +16200,46 @@
               </a:rPr>
               <a:t>跨專線進度</a:t>
             </a:r>
-            <a:endParaRPr sz="2800" b="1" dirty="0">
+            <a:br>
+              <a:rPr lang="en-US" sz="2800" b="1" dirty="0">
+                <a:solidFill>
+                  <a:srgbClr val="FFFFFF"/>
+                </a:solidFill>
+              </a:rPr>
+            </a:br>
+            <a:r>
+              <a:rPr lang="en-US" altLang="zh-TW" sz="1600" b="1" dirty="0">
+                <a:solidFill>
+                  <a:srgbClr val="FFFFFF"/>
+                </a:solidFill>
+              </a:rPr>
+              <a:t>{FIXME} </a:t>
+            </a:r>
+            <a:r>
+              <a:rPr lang="zh-TW" altLang="en-US" sz="1600" b="1" dirty="0">
+                <a:solidFill>
+                  <a:srgbClr val="FFFFFF"/>
+                </a:solidFill>
+              </a:rPr>
+              <a:t>架構圖示說明解釋</a:t>
+            </a:r>
+            <a:r>
+              <a:rPr lang="en-US" altLang="zh-TW" sz="1600" b="1" dirty="0">
+                <a:solidFill>
+                  <a:srgbClr val="FFFFFF"/>
+                </a:solidFill>
+              </a:rPr>
+              <a:t> </a:t>
+            </a:r>
+            <a:r>
+              <a:rPr lang="en" altLang="zh-TW" sz="1600" b="1" dirty="0">
+                <a:solidFill>
+                  <a:srgbClr val="FFFFFF"/>
+                </a:solidFill>
+              </a:rPr>
+              <a:t>P-A/P-B  placement</a:t>
+            </a:r>
+            <a:endParaRPr sz="1600" b="1" dirty="0">
               <a:solidFill>
                 <a:srgbClr val="FFFFFF"/>
               </a:solidFill>
@@ -16193,7 +16518,23 @@
                   <a:srgbClr val="FFFFFF"/>
                 </a:solidFill>
               </a:rPr>
-              <a:t>）</a:t>
+              <a:t> ; </a:t>
+            </a:r>
+            <a:r>
+              <a:rPr lang="en" sz="1200" dirty="0" err="1">
+                <a:solidFill>
+                  <a:srgbClr val="FFFFFF"/>
+                </a:solidFill>
+              </a:rPr>
+              <a:t>時間偏移</a:t>
+            </a:r>
+            <a:r>
+              <a:rPr lang="en" sz="1200" dirty="0">
+                <a:solidFill>
+                  <a:srgbClr val="FFFFFF"/>
+                </a:solidFill>
+              </a:rPr>
+              <a:t> between IDC &amp; GCP）</a:t>
             </a:r>
           </a:p>
           <a:p>

</xml_diff>